<commit_message>
Vecka 43: figurer, texträttelser och Hållkretslabbet (före granskning)
Co-Authored-By: Claude Opus 5.5 <noreply@anthropic.com>
Claude-Session: https://claude.ai/code/session_011V9KjBb53XrDm23Dw58SH3
</commit_message>
<xml_diff>
--- a/sjoskolan/vecka-43/aktuell/v43_01_Komponenter_och_skydd_elev.pptx
+++ b/sjoskolan/vecka-43/aktuell/v43_01_Komponenter_och_skydd_elev.pptx
@@ -5979,7 +5979,7 @@
         <p:spPr>
           <a:xfrm xmlns:a="http://schemas.openxmlformats.org/drawingml/2006/main">
             <a:off x="762000" y="1638300"/>
-            <a:ext cx="7620000" cy="876300"/>
+            <a:ext cx="3977639" cy="876300"/>
           </a:xfrm>
           <a:prstGeom xmlns:a="http://schemas.openxmlformats.org/drawingml/2006/main" prst="rect">
             <a:avLst/>
@@ -6014,7 +6014,95 @@
                 <a:ea typeface="Calibri"/>
                 <a:cs typeface="Calibri"/>
               </a:rPr>
-              <a:t>IΔ = |Iut − Iretur|</a:t>
+              <a:t>I</a:t>
+            </a:r>
+            <a:r>
+              <a:rPr sz="2400" b="1" baseline="-25000">
+                <a:solidFill>
+                  <a:srgbClr val="064F91"/>
+                </a:solidFill>
+                <a:latin typeface="Calibri"/>
+                <a:ea typeface="Calibri"/>
+                <a:cs typeface="Calibri"/>
+              </a:rPr>
+              <a:t>Δ</a:t>
+            </a:r>
+            <a:r>
+              <a:rPr sz="2400" b="1">
+                <a:solidFill>
+                  <a:srgbClr val="064F91"/>
+                </a:solidFill>
+                <a:latin typeface="Calibri"/>
+                <a:ea typeface="Calibri"/>
+                <a:cs typeface="Calibri"/>
+              </a:rPr>
+              <a:t> = |</a:t>
+            </a:r>
+            <a:r>
+              <a:rPr sz="2400" b="1">
+                <a:solidFill>
+                  <a:srgbClr val="064F91"/>
+                </a:solidFill>
+                <a:latin typeface="Calibri"/>
+                <a:ea typeface="Calibri"/>
+                <a:cs typeface="Calibri"/>
+              </a:rPr>
+              <a:t>I</a:t>
+            </a:r>
+            <a:r>
+              <a:rPr sz="2400" b="1" baseline="-25000">
+                <a:solidFill>
+                  <a:srgbClr val="064F91"/>
+                </a:solidFill>
+                <a:latin typeface="Calibri"/>
+                <a:ea typeface="Calibri"/>
+                <a:cs typeface="Calibri"/>
+              </a:rPr>
+              <a:t>ut</a:t>
+            </a:r>
+            <a:r>
+              <a:rPr sz="2400" b="1">
+                <a:solidFill>
+                  <a:srgbClr val="064F91"/>
+                </a:solidFill>
+                <a:latin typeface="Calibri"/>
+                <a:ea typeface="Calibri"/>
+                <a:cs typeface="Calibri"/>
+              </a:rPr>
+              <a:t> − </a:t>
+            </a:r>
+            <a:r>
+              <a:rPr sz="2400" b="1">
+                <a:solidFill>
+                  <a:srgbClr val="064F91"/>
+                </a:solidFill>
+                <a:latin typeface="Calibri"/>
+                <a:ea typeface="Calibri"/>
+                <a:cs typeface="Calibri"/>
+              </a:rPr>
+              <a:t>I</a:t>
+            </a:r>
+            <a:r>
+              <a:rPr sz="2400" b="1" baseline="-25000">
+                <a:solidFill>
+                  <a:srgbClr val="064F91"/>
+                </a:solidFill>
+                <a:latin typeface="Calibri"/>
+                <a:ea typeface="Calibri"/>
+                <a:cs typeface="Calibri"/>
+              </a:rPr>
+              <a:t>retur</a:t>
+            </a:r>
+            <a:r>
+              <a:rPr sz="2400" b="1">
+                <a:solidFill>
+                  <a:srgbClr val="064F91"/>
+                </a:solidFill>
+                <a:latin typeface="Calibri"/>
+                <a:ea typeface="Calibri"/>
+                <a:cs typeface="Calibri"/>
+              </a:rPr>
+              <a:t>|</a:t>
             </a:r>
           </a:p>
         </p:txBody>
@@ -6036,7 +6124,7 @@
         <p:spPr>
           <a:xfrm xmlns:a="http://schemas.openxmlformats.org/drawingml/2006/main">
             <a:off x="762000" y="2667000"/>
-            <a:ext cx="7620000" cy="952500"/>
+            <a:ext cx="3977639" cy="952500"/>
           </a:xfrm>
           <a:prstGeom xmlns:a="http://schemas.openxmlformats.org/drawingml/2006/main" prst="rect">
             <a:avLst/>
@@ -6063,15 +6151,37 @@
               </a:defRPr>
             </a:pPr>
             <a:r>
-              <a:rPr sz="2100" b="0">
-                <a:solidFill>
-                  <a:srgbClr val="111111"/>
-                </a:solidFill>
-                <a:latin typeface="Calibri"/>
-                <a:ea typeface="Calibri"/>
-                <a:cs typeface="Calibri"/>
-              </a:rPr>
-              <a:t>IΔ är differensström i A. Multiplicera med 1 000 för mA.</a:t>
+              <a:rPr sz="2050" b="0">
+                <a:solidFill>
+                  <a:srgbClr val="111111"/>
+                </a:solidFill>
+                <a:latin typeface="Calibri"/>
+                <a:ea typeface="Calibri"/>
+                <a:cs typeface="Calibri"/>
+              </a:rPr>
+              <a:t>I</a:t>
+            </a:r>
+            <a:r>
+              <a:rPr sz="2050" b="0" baseline="-25000">
+                <a:solidFill>
+                  <a:srgbClr val="111111"/>
+                </a:solidFill>
+                <a:latin typeface="Calibri"/>
+                <a:ea typeface="Calibri"/>
+                <a:cs typeface="Calibri"/>
+              </a:rPr>
+              <a:t>Δ</a:t>
+            </a:r>
+            <a:r>
+              <a:rPr sz="2050" b="0">
+                <a:solidFill>
+                  <a:srgbClr val="111111"/>
+                </a:solidFill>
+                <a:latin typeface="Calibri"/>
+                <a:ea typeface="Calibri"/>
+                <a:cs typeface="Calibri"/>
+              </a:rPr>
+              <a:t> är differensström i A. Multiplicera med 1 000 för mA.</a:t>
             </a:r>
           </a:p>
         </p:txBody>
@@ -6093,7 +6203,7 @@
         <p:spPr>
           <a:xfrm xmlns:a="http://schemas.openxmlformats.org/drawingml/2006/main">
             <a:off x="762000" y="3800475"/>
-            <a:ext cx="7620000" cy="981075"/>
+            <a:ext cx="3977639" cy="981075"/>
           </a:xfrm>
           <a:prstGeom xmlns:a="http://schemas.openxmlformats.org/drawingml/2006/main" prst="rect">
             <a:avLst/>
@@ -6120,15 +6230,15 @@
               </a:defRPr>
             </a:pPr>
             <a:r>
-              <a:rPr sz="2025" b="0">
-                <a:solidFill>
-                  <a:srgbClr val="111111"/>
-                </a:solidFill>
-                <a:latin typeface="Calibri"/>
-                <a:ea typeface="Calibri"/>
-                <a:cs typeface="Calibri"/>
-              </a:rPr>
-              <a:t>Förutsättningar: Samtidiga enfasströmmar: 5,000 A ut och 4,970 A tillbaka. De angivna beloppen jämförs i modellen.</a:t>
+              <a:rPr sz="1600" b="0">
+                <a:solidFill>
+                  <a:srgbClr val="111111"/>
+                </a:solidFill>
+                <a:latin typeface="Calibri"/>
+                <a:ea typeface="Calibri"/>
+                <a:cs typeface="Calibri"/>
+              </a:rPr>
+              <a:t>Förutsättningar: Samtidiga enfasströmmar: 5,000 A ut och 4,970 A tillbaka. De angivna beloppen jämförs i modellen.</a:t>
             </a:r>
           </a:p>
         </p:txBody>
@@ -6150,7 +6260,7 @@
         <p:spPr>
           <a:xfrm xmlns:a="http://schemas.openxmlformats.org/drawingml/2006/main">
             <a:off x="762000" y="5010150"/>
-            <a:ext cx="7620000" cy="990600"/>
+            <a:ext cx="3977639" cy="990600"/>
           </a:xfrm>
           <a:prstGeom xmlns:a="http://schemas.openxmlformats.org/drawingml/2006/main" prst="rect">
             <a:avLst/>
@@ -6247,6 +6357,30 @@
           </a:p>
         </p:txBody>
       </p:sp>
+      <p:pic xmlns:a="http://schemas.openxmlformats.org/drawingml/2006/main" xmlns:r="http://schemas.openxmlformats.org/officeDocument/2006/relationships">
+        <p:nvPicPr>
+          <p:cNvPr id="16" name="Figur: Jordfelsbrytare med 5,000 A ut och 4,970" descr="Jordfelsbrytare med 5,000 A ut och 4,970 A tillbaka; differensströmmen okänd"/>
+          <p:cNvPicPr>
+            <a:picLocks noChangeAspect="1"/>
+          </p:cNvPicPr>
+          <p:nvPr/>
+        </p:nvPicPr>
+        <p:blipFill>
+          <a:blip r:embed="rId3"/>
+          <a:stretch>
+            <a:fillRect/>
+          </a:stretch>
+        </p:blipFill>
+        <p:spPr>
+          <a:xfrm>
+            <a:off x="4892040" y="1645920"/>
+            <a:ext cx="3886200" cy="3071293"/>
+          </a:xfrm>
+          <a:prstGeom prst="rect">
+            <a:avLst/>
+          </a:prstGeom>
+        </p:spPr>
+      </p:pic>
     </p:spTree>
     <p:extLst>
       <p:ext uri="{BB962C8B-B14F-4D97-AF65-F5344CB8AC3E}">
@@ -6703,7 +6837,7 @@
         <p:spPr>
           <a:xfrm xmlns:a="http://schemas.openxmlformats.org/drawingml/2006/main">
             <a:off x="762000" y="1638300"/>
-            <a:ext cx="7620000" cy="876300"/>
+            <a:ext cx="3977639" cy="876300"/>
           </a:xfrm>
           <a:prstGeom xmlns:a="http://schemas.openxmlformats.org/drawingml/2006/main" prst="rect">
             <a:avLst/>
@@ -6760,7 +6894,7 @@
         <p:spPr>
           <a:xfrm xmlns:a="http://schemas.openxmlformats.org/drawingml/2006/main">
             <a:off x="762000" y="2667000"/>
-            <a:ext cx="7620000" cy="952500"/>
+            <a:ext cx="3977639" cy="952500"/>
           </a:xfrm>
           <a:prstGeom xmlns:a="http://schemas.openxmlformats.org/drawingml/2006/main" prst="rect">
             <a:avLst/>
@@ -6787,7 +6921,7 @@
               </a:defRPr>
             </a:pPr>
             <a:r>
-              <a:rPr sz="2100" b="0">
+              <a:rPr sz="1650" b="0">
                 <a:solidFill>
                   <a:srgbClr val="111111"/>
                 </a:solidFill>
@@ -6817,7 +6951,7 @@
         <p:spPr>
           <a:xfrm xmlns:a="http://schemas.openxmlformats.org/drawingml/2006/main">
             <a:off x="762000" y="3800475"/>
-            <a:ext cx="7620000" cy="981075"/>
+            <a:ext cx="3977639" cy="981075"/>
           </a:xfrm>
           <a:prstGeom xmlns:a="http://schemas.openxmlformats.org/drawingml/2006/main" prst="rect">
             <a:avLst/>
@@ -6844,7 +6978,7 @@
               </a:defRPr>
             </a:pPr>
             <a:r>
-              <a:rPr sz="2025" b="0">
+              <a:rPr sz="1600" b="0">
                 <a:solidFill>
                   <a:srgbClr val="111111"/>
                 </a:solidFill>
@@ -6874,7 +7008,7 @@
         <p:spPr>
           <a:xfrm xmlns:a="http://schemas.openxmlformats.org/drawingml/2006/main">
             <a:off x="762000" y="5010150"/>
-            <a:ext cx="7620000" cy="990600"/>
+            <a:ext cx="3977639" cy="990600"/>
           </a:xfrm>
           <a:prstGeom xmlns:a="http://schemas.openxmlformats.org/drawingml/2006/main" prst="rect">
             <a:avLst/>
@@ -6901,7 +7035,7 @@
               </a:defRPr>
             </a:pPr>
             <a:r>
-              <a:rPr sz="2025" b="0">
+              <a:rPr sz="1600" b="0">
                 <a:solidFill>
                   <a:srgbClr val="111111"/>
                 </a:solidFill>
@@ -6971,6 +7105,30 @@
           </a:p>
         </p:txBody>
       </p:sp>
+      <p:pic xmlns:a="http://schemas.openxmlformats.org/drawingml/2006/main" xmlns:r="http://schemas.openxmlformats.org/officeDocument/2006/relationships">
+        <p:nvPicPr>
+          <p:cNvPr id="16" name="Figur: Jordfelsbrytare där lasten drar för stor" descr="Jordfelsbrytare där lasten drar för stor ström men samma ström kommer tillbaka; differensströmmen ungefär noll"/>
+          <p:cNvPicPr>
+            <a:picLocks noChangeAspect="1"/>
+          </p:cNvPicPr>
+          <p:nvPr/>
+        </p:nvPicPr>
+        <p:blipFill>
+          <a:blip r:embed="rId3"/>
+          <a:stretch>
+            <a:fillRect/>
+          </a:stretch>
+        </p:blipFill>
+        <p:spPr>
+          <a:xfrm>
+            <a:off x="4892040" y="1645920"/>
+            <a:ext cx="3886200" cy="3071293"/>
+          </a:xfrm>
+          <a:prstGeom prst="rect">
+            <a:avLst/>
+          </a:prstGeom>
+        </p:spPr>
+      </p:pic>
     </p:spTree>
     <p:extLst>
       <p:ext uri="{BB962C8B-B14F-4D97-AF65-F5344CB8AC3E}">
@@ -8172,7 +8330,7 @@
         <p:spPr>
           <a:xfrm xmlns:a="http://schemas.openxmlformats.org/drawingml/2006/main">
             <a:off x="762000" y="1619250"/>
-            <a:ext cx="7620000" cy="1466850"/>
+            <a:ext cx="3977639" cy="1466850"/>
           </a:xfrm>
           <a:prstGeom xmlns:a="http://schemas.openxmlformats.org/drawingml/2006/main" prst="rect">
             <a:avLst/>
@@ -8200,7 +8358,7 @@
               </a:defRPr>
             </a:pPr>
             <a:r>
-              <a:rPr sz="2400" b="0">
+              <a:rPr sz="1950" b="0">
                 <a:solidFill>
                   <a:srgbClr val="111111"/>
                 </a:solidFill>
@@ -8224,7 +8382,7 @@
               </a:defRPr>
             </a:pPr>
             <a:r>
-              <a:rPr sz="2400" b="0">
+              <a:rPr sz="1950" b="0">
                 <a:solidFill>
                   <a:srgbClr val="111111"/>
                 </a:solidFill>
@@ -8254,7 +8412,7 @@
         <p:spPr>
           <a:xfrm xmlns:a="http://schemas.openxmlformats.org/drawingml/2006/main">
             <a:off x="762000" y="3200400"/>
-            <a:ext cx="7620000" cy="838200"/>
+            <a:ext cx="3977639" cy="838200"/>
           </a:xfrm>
           <a:prstGeom xmlns:a="http://schemas.openxmlformats.org/drawingml/2006/main" prst="rect">
             <a:avLst/>
@@ -8282,7 +8440,7 @@
               </a:defRPr>
             </a:pPr>
             <a:r>
-              <a:rPr sz="2925" b="1">
+              <a:rPr sz="2650" b="1">
                 <a:solidFill>
                   <a:srgbClr val="064F91"/>
                 </a:solidFill>
@@ -8312,7 +8470,7 @@
         <p:spPr>
           <a:xfrm xmlns:a="http://schemas.openxmlformats.org/drawingml/2006/main">
             <a:off x="762000" y="4429125"/>
-            <a:ext cx="7620000" cy="1352550"/>
+            <a:ext cx="3977639" cy="1352550"/>
           </a:xfrm>
           <a:prstGeom xmlns:a="http://schemas.openxmlformats.org/drawingml/2006/main" prst="rect">
             <a:avLst/>
@@ -8340,7 +8498,7 @@
               </a:defRPr>
             </a:pPr>
             <a:r>
-              <a:rPr sz="2250" b="0">
+              <a:rPr sz="1850" b="0">
                 <a:solidFill>
                   <a:srgbClr val="111111"/>
                 </a:solidFill>
@@ -8364,7 +8522,7 @@
               </a:defRPr>
             </a:pPr>
             <a:r>
-              <a:rPr sz="2250" b="0">
+              <a:rPr sz="1850" b="0">
                 <a:solidFill>
                   <a:srgbClr val="111111"/>
                 </a:solidFill>
@@ -8435,6 +8593,30 @@
           </a:p>
         </p:txBody>
       </p:sp>
+      <p:pic xmlns:a="http://schemas.openxmlformats.org/drawingml/2006/main" xmlns:r="http://schemas.openxmlformats.org/officeDocument/2006/relationships">
+        <p:nvPicPr>
+          <p:cNvPr id="9" name="Figur: Kontaktor K1 i opåverkat läge: spolen, e" descr="Kontaktor K1 i opåverkat läge: spolen, en NO-kontakt 13–14 som är öppen och en NC-kontakt 21–22 som är sluten"/>
+          <p:cNvPicPr>
+            <a:picLocks noChangeAspect="1"/>
+          </p:cNvPicPr>
+          <p:nvPr/>
+        </p:nvPicPr>
+        <p:blipFill>
+          <a:blip r:embed="rId3"/>
+          <a:stretch>
+            <a:fillRect/>
+          </a:stretch>
+        </p:blipFill>
+        <p:spPr>
+          <a:xfrm>
+            <a:off x="4892040" y="1645920"/>
+            <a:ext cx="3886200" cy="2890202"/>
+          </a:xfrm>
+          <a:prstGeom prst="rect">
+            <a:avLst/>
+          </a:prstGeom>
+        </p:spPr>
+      </p:pic>
     </p:spTree>
     <p:extLst>
       <p:ext uri="{BB962C8B-B14F-4D97-AF65-F5344CB8AC3E}">
@@ -8940,7 +9122,7 @@
         <p:spPr>
           <a:xfrm xmlns:a="http://schemas.openxmlformats.org/drawingml/2006/main">
             <a:off x="762000" y="1619250"/>
-            <a:ext cx="7620000" cy="1466850"/>
+            <a:ext cx="3977639" cy="1466850"/>
           </a:xfrm>
           <a:prstGeom xmlns:a="http://schemas.openxmlformats.org/drawingml/2006/main" prst="rect">
             <a:avLst/>
@@ -8968,7 +9150,7 @@
               </a:defRPr>
             </a:pPr>
             <a:r>
-              <a:rPr sz="2400" b="0">
+              <a:rPr sz="1800" b="0">
                 <a:solidFill>
                   <a:srgbClr val="111111"/>
                 </a:solidFill>
@@ -8992,7 +9174,7 @@
               </a:defRPr>
             </a:pPr>
             <a:r>
-              <a:rPr sz="2400" b="0">
+              <a:rPr sz="1800" b="0">
                 <a:solidFill>
                   <a:srgbClr val="111111"/>
                 </a:solidFill>
@@ -9022,7 +9204,7 @@
         <p:spPr>
           <a:xfrm xmlns:a="http://schemas.openxmlformats.org/drawingml/2006/main">
             <a:off x="762000" y="3200400"/>
-            <a:ext cx="7620000" cy="838200"/>
+            <a:ext cx="3977639" cy="838200"/>
           </a:xfrm>
           <a:prstGeom xmlns:a="http://schemas.openxmlformats.org/drawingml/2006/main" prst="rect">
             <a:avLst/>
@@ -9050,7 +9232,7 @@
               </a:defRPr>
             </a:pPr>
             <a:r>
-              <a:rPr sz="2925" b="1">
+              <a:rPr sz="2550" b="1">
                 <a:solidFill>
                   <a:srgbClr val="064F91"/>
                 </a:solidFill>
@@ -9080,7 +9262,7 @@
         <p:spPr>
           <a:xfrm xmlns:a="http://schemas.openxmlformats.org/drawingml/2006/main">
             <a:off x="762000" y="4429125"/>
-            <a:ext cx="7620000" cy="1352550"/>
+            <a:ext cx="3977639" cy="1352550"/>
           </a:xfrm>
           <a:prstGeom xmlns:a="http://schemas.openxmlformats.org/drawingml/2006/main" prst="rect">
             <a:avLst/>
@@ -9108,7 +9290,7 @@
               </a:defRPr>
             </a:pPr>
             <a:r>
-              <a:rPr sz="2250" b="0">
+              <a:rPr sz="1850" b="0">
                 <a:solidFill>
                   <a:srgbClr val="111111"/>
                 </a:solidFill>
@@ -9132,7 +9314,7 @@
               </a:defRPr>
             </a:pPr>
             <a:r>
-              <a:rPr sz="2250" b="0">
+              <a:rPr sz="1850" b="0">
                 <a:solidFill>
                   <a:srgbClr val="111111"/>
                 </a:solidFill>
@@ -9203,6 +9385,30 @@
           </a:p>
         </p:txBody>
       </p:sp>
+      <p:pic xmlns:a="http://schemas.openxmlformats.org/drawingml/2006/main" xmlns:r="http://schemas.openxmlformats.org/officeDocument/2006/relationships">
+        <p:nvPicPr>
+          <p:cNvPr id="9" name="Figur: Huvudskydd och tre gruppskydd; vid fel i" descr="Huvudskydd och tre gruppskydd; vid fel i grupp B löser bara grupp B medan övriga är i drift"/>
+          <p:cNvPicPr>
+            <a:picLocks noChangeAspect="1"/>
+          </p:cNvPicPr>
+          <p:nvPr/>
+        </p:nvPicPr>
+        <p:blipFill>
+          <a:blip r:embed="rId3"/>
+          <a:stretch>
+            <a:fillRect/>
+          </a:stretch>
+        </p:blipFill>
+        <p:spPr>
+          <a:xfrm>
+            <a:off x="4892040" y="1645920"/>
+            <a:ext cx="3886200" cy="3252383"/>
+          </a:xfrm>
+          <a:prstGeom prst="rect">
+            <a:avLst/>
+          </a:prstGeom>
+        </p:spPr>
+      </p:pic>
     </p:spTree>
     <p:extLst>
       <p:ext uri="{BB962C8B-B14F-4D97-AF65-F5344CB8AC3E}">
@@ -9323,7 +9529,7 @@
         <p:spPr>
           <a:xfrm xmlns:a="http://schemas.openxmlformats.org/drawingml/2006/main">
             <a:off x="762000" y="1571625"/>
-            <a:ext cx="7620000" cy="990600"/>
+            <a:ext cx="3977639" cy="990600"/>
           </a:xfrm>
           <a:prstGeom xmlns:a="http://schemas.openxmlformats.org/drawingml/2006/main" prst="rect">
             <a:avLst/>
@@ -9350,7 +9556,7 @@
               </a:defRPr>
             </a:pPr>
             <a:r>
-              <a:rPr sz="2175" b="0">
+              <a:rPr sz="1650" b="0">
                 <a:solidFill>
                   <a:srgbClr val="111111"/>
                 </a:solidFill>
@@ -9380,7 +9586,7 @@
         <p:spPr>
           <a:xfrm xmlns:a="http://schemas.openxmlformats.org/drawingml/2006/main">
             <a:off x="762000" y="2705100"/>
-            <a:ext cx="7620000" cy="790575"/>
+            <a:ext cx="3977639" cy="790575"/>
           </a:xfrm>
           <a:prstGeom xmlns:a="http://schemas.openxmlformats.org/drawingml/2006/main" prst="rect">
             <a:avLst/>
@@ -9437,7 +9643,7 @@
         <p:spPr>
           <a:xfrm xmlns:a="http://schemas.openxmlformats.org/drawingml/2006/main">
             <a:off x="762000" y="3657600"/>
-            <a:ext cx="7620000" cy="1524000"/>
+            <a:ext cx="3977639" cy="1524000"/>
           </a:xfrm>
           <a:prstGeom xmlns:a="http://schemas.openxmlformats.org/drawingml/2006/main" prst="rect">
             <a:avLst/>
@@ -9464,7 +9670,7 @@
               </a:defRPr>
             </a:pPr>
             <a:r>
-              <a:rPr sz="2063" b="0">
+              <a:rPr sz="1650" b="0">
                 <a:solidFill>
                   <a:srgbClr val="111111"/>
                 </a:solidFill>
@@ -9487,7 +9693,7 @@
               </a:defRPr>
             </a:pPr>
             <a:r>
-              <a:rPr sz="2063" b="0">
+              <a:rPr sz="1650" b="0">
                 <a:solidFill>
                   <a:srgbClr val="111111"/>
                 </a:solidFill>
@@ -9510,7 +9716,7 @@
               </a:defRPr>
             </a:pPr>
             <a:r>
-              <a:rPr sz="2063" b="0">
+              <a:rPr sz="1650" b="0">
                 <a:solidFill>
                   <a:srgbClr val="111111"/>
                 </a:solidFill>
@@ -9540,7 +9746,7 @@
         <p:spPr>
           <a:xfrm xmlns:a="http://schemas.openxmlformats.org/drawingml/2006/main">
             <a:off x="762000" y="5372100"/>
-            <a:ext cx="7620000" cy="685800"/>
+            <a:ext cx="3977639" cy="685800"/>
           </a:xfrm>
           <a:prstGeom xmlns:a="http://schemas.openxmlformats.org/drawingml/2006/main" prst="rect">
             <a:avLst/>
@@ -9567,7 +9773,7 @@
               </a:defRPr>
             </a:pPr>
             <a:r>
-              <a:rPr sz="1913" b="0">
+              <a:rPr sz="1550" b="0">
                 <a:solidFill>
                   <a:srgbClr val="111111"/>
                 </a:solidFill>
@@ -9637,6 +9843,30 @@
           </a:p>
         </p:txBody>
       </p:sp>
+      <p:pic xmlns:a="http://schemas.openxmlformats.org/drawingml/2006/main" xmlns:r="http://schemas.openxmlformats.org/officeDocument/2006/relationships">
+        <p:nvPicPr>
+          <p:cNvPr id="16" name="Figur: Stapeldiagram: skydd A har 4,5 kA och sk" descr="Stapeldiagram: skydd A har 4,5 kA och skydd B 10 kA brytförmåga jämfört med möjlig felström 7 kA"/>
+          <p:cNvPicPr>
+            <a:picLocks noChangeAspect="1"/>
+          </p:cNvPicPr>
+          <p:nvPr/>
+        </p:nvPicPr>
+        <p:blipFill>
+          <a:blip r:embed="rId3"/>
+          <a:stretch>
+            <a:fillRect/>
+          </a:stretch>
+        </p:blipFill>
+        <p:spPr>
+          <a:xfrm>
+            <a:off x="4892040" y="1645920"/>
+            <a:ext cx="3886200" cy="2890202"/>
+          </a:xfrm>
+          <a:prstGeom prst="rect">
+            <a:avLst/>
+          </a:prstGeom>
+        </p:spPr>
+      </p:pic>
     </p:spTree>
     <p:extLst>
       <p:ext uri="{BB962C8B-B14F-4D97-AF65-F5344CB8AC3E}">
@@ -14414,64 +14644,6 @@
       </p:sp>
       <p:sp>
         <p:nvSpPr>
-          <p:cNvPr id="7" name="Källor och lärarstöd finns även i bildanteckningarna.">
-            <a:extLst xmlns:a="http://schemas.openxmlformats.org/drawingml/2006/main">
-              <a:ext uri="{FF2B5EF4-FFF2-40B4-BE49-F238E27FC236}">
-                <a16:creationId xmlns:a16="http://schemas.microsoft.com/office/drawing/2014/main" id="{F87A575E-EB5A-4C88-98E3-4E2815399B23}"/>
-              </a:ext>
-            </a:extLst>
-          </p:cNvPr>
-          <p:cNvSpPr>
-            <a:spLocks xmlns:a="http://schemas.openxmlformats.org/drawingml/2006/main" noGrp="1"/>
-          </p:cNvSpPr>
-          <p:nvPr/>
-        </p:nvSpPr>
-        <p:spPr>
-          <a:xfrm xmlns:a="http://schemas.openxmlformats.org/drawingml/2006/main">
-            <a:off x="762000" y="5676900"/>
-            <a:ext cx="7620000" cy="352425"/>
-          </a:xfrm>
-          <a:prstGeom xmlns:a="http://schemas.openxmlformats.org/drawingml/2006/main" prst="rect">
-            <a:avLst/>
-          </a:prstGeom>
-          <a:noFill xmlns:a="http://schemas.openxmlformats.org/drawingml/2006/main"/>
-          <a:ln xmlns:a="http://schemas.openxmlformats.org/drawingml/2006/main" w="0">
-            <a:noFill/>
-          </a:ln>
-        </p:spPr>
-        <p:txBody>
-          <a:bodyPr xmlns:a="http://schemas.openxmlformats.org/drawingml/2006/main" wrap="square" lIns="0" tIns="0" rIns="0" bIns="0" anchor="t">
-            <a:noAutofit/>
-          </a:bodyPr>
-          <a:lstStyle xmlns:a="http://schemas.openxmlformats.org/drawingml/2006/main"/>
-          <a:p xmlns:a="http://schemas.openxmlformats.org/drawingml/2006/main">
-            <a:pPr algn="l">
-              <a:buNone/>
-              <a:defRPr sz="1800" b="0">
-                <a:solidFill>
-                  <a:srgbClr val="111111"/>
-                </a:solidFill>
-                <a:latin typeface="Calibri"/>
-                <a:ea typeface="Calibri"/>
-                <a:cs typeface="Calibri"/>
-              </a:defRPr>
-            </a:pPr>
-            <a:r>
-              <a:rPr sz="1800" b="0">
-                <a:solidFill>
-                  <a:srgbClr val="111111"/>
-                </a:solidFill>
-                <a:latin typeface="Calibri"/>
-                <a:ea typeface="Calibri"/>
-                <a:cs typeface="Calibri"/>
-              </a:rPr>
-              <a:t>Källor och lärarstöd finns även i bildanteckningarna.</a:t>
-            </a:r>
-          </a:p>
-        </p:txBody>
-      </p:sp>
-      <p:sp>
-        <p:nvSpPr>
           <p:cNvPr id="8" name="22">
             <a:extLst xmlns:a="http://schemas.openxmlformats.org/drawingml/2006/main">
               <a:ext uri="{FF2B5EF4-FFF2-40B4-BE49-F238E27FC236}">
@@ -15946,7 +16118,7 @@
         <p:spPr>
           <a:xfrm xmlns:a="http://schemas.openxmlformats.org/drawingml/2006/main">
             <a:off x="762000" y="1619250"/>
-            <a:ext cx="7620000" cy="1466850"/>
+            <a:ext cx="3977639" cy="1466850"/>
           </a:xfrm>
           <a:prstGeom xmlns:a="http://schemas.openxmlformats.org/drawingml/2006/main" prst="rect">
             <a:avLst/>
@@ -15974,7 +16146,7 @@
               </a:defRPr>
             </a:pPr>
             <a:r>
-              <a:rPr sz="2400" b="0">
+              <a:rPr sz="2050" b="0">
                 <a:solidFill>
                   <a:srgbClr val="111111"/>
                 </a:solidFill>
@@ -15998,7 +16170,7 @@
               </a:defRPr>
             </a:pPr>
             <a:r>
-              <a:rPr sz="2400" b="0">
+              <a:rPr sz="2050" b="0">
                 <a:solidFill>
                   <a:srgbClr val="111111"/>
                 </a:solidFill>
@@ -16028,7 +16200,7 @@
         <p:spPr>
           <a:xfrm xmlns:a="http://schemas.openxmlformats.org/drawingml/2006/main">
             <a:off x="762000" y="3200400"/>
-            <a:ext cx="7620000" cy="838200"/>
+            <a:ext cx="3977639" cy="838200"/>
           </a:xfrm>
           <a:prstGeom xmlns:a="http://schemas.openxmlformats.org/drawingml/2006/main" prst="rect">
             <a:avLst/>
@@ -16056,7 +16228,7 @@
               </a:defRPr>
             </a:pPr>
             <a:r>
-              <a:rPr sz="2925" b="1">
+              <a:rPr sz="2550" b="1">
                 <a:solidFill>
                   <a:srgbClr val="064F91"/>
                 </a:solidFill>
@@ -16086,7 +16258,7 @@
         <p:spPr>
           <a:xfrm xmlns:a="http://schemas.openxmlformats.org/drawingml/2006/main">
             <a:off x="762000" y="4429125"/>
-            <a:ext cx="7620000" cy="1352550"/>
+            <a:ext cx="3977639" cy="1352550"/>
           </a:xfrm>
           <a:prstGeom xmlns:a="http://schemas.openxmlformats.org/drawingml/2006/main" prst="rect">
             <a:avLst/>
@@ -16114,15 +16286,15 @@
               </a:defRPr>
             </a:pPr>
             <a:r>
-              <a:rPr sz="2250" b="0">
-                <a:solidFill>
-                  <a:srgbClr val="111111"/>
-                </a:solidFill>
-                <a:latin typeface="Calibri"/>
-                <a:ea typeface="Calibri"/>
-                <a:cs typeface="Calibri"/>
-              </a:rPr>
-              <a:t>Ett skydd märkt 16 A kan tåla normal lastström.</a:t>
+              <a:rPr sz="1850" b="0">
+                <a:solidFill>
+                  <a:srgbClr val="111111"/>
+                </a:solidFill>
+                <a:latin typeface="Calibri"/>
+                <a:ea typeface="Calibri"/>
+                <a:cs typeface="Calibri"/>
+              </a:rPr>
+              <a:t>Ett skydd märkt 16 A kan tåla normal lastström.</a:t>
             </a:r>
           </a:p>
           <a:p xmlns:a="http://schemas.openxmlformats.org/drawingml/2006/main">
@@ -16138,7 +16310,7 @@
               </a:defRPr>
             </a:pPr>
             <a:r>
-              <a:rPr sz="2250" b="0">
+              <a:rPr sz="1850" b="0">
                 <a:solidFill>
                   <a:srgbClr val="111111"/>
                 </a:solidFill>
@@ -16209,6 +16381,30 @@
           </a:p>
         </p:txBody>
       </p:sp>
+      <p:pic xmlns:a="http://schemas.openxmlformats.org/drawingml/2006/main" xmlns:r="http://schemas.openxmlformats.org/officeDocument/2006/relationships">
+        <p:nvPicPr>
+          <p:cNvPr id="9" name="Figur: Principskiss av en ström–tidskurva: lång" descr="Principskiss av en ström–tidskurva: långsam utlösning vid överlast och snabb vid kortslutning"/>
+          <p:cNvPicPr>
+            <a:picLocks noChangeAspect="1"/>
+          </p:cNvPicPr>
+          <p:nvPr/>
+        </p:nvPicPr>
+        <p:blipFill>
+          <a:blip r:embed="rId3"/>
+          <a:stretch>
+            <a:fillRect/>
+          </a:stretch>
+        </p:blipFill>
+        <p:spPr>
+          <a:xfrm>
+            <a:off x="4892040" y="1645920"/>
+            <a:ext cx="3886200" cy="3252383"/>
+          </a:xfrm>
+          <a:prstGeom prst="rect">
+            <a:avLst/>
+          </a:prstGeom>
+        </p:spPr>
+      </p:pic>
     </p:spTree>
     <p:extLst>
       <p:ext uri="{BB962C8B-B14F-4D97-AF65-F5344CB8AC3E}">
@@ -16330,7 +16526,7 @@
         <p:spPr>
           <a:xfrm xmlns:a="http://schemas.openxmlformats.org/drawingml/2006/main">
             <a:off x="762000" y="1619250"/>
-            <a:ext cx="7620000" cy="1466850"/>
+            <a:ext cx="3977639" cy="1466850"/>
           </a:xfrm>
           <a:prstGeom xmlns:a="http://schemas.openxmlformats.org/drawingml/2006/main" prst="rect">
             <a:avLst/>
@@ -16358,7 +16554,7 @@
               </a:defRPr>
             </a:pPr>
             <a:r>
-              <a:rPr sz="2400" b="0">
+              <a:rPr sz="2050" b="0">
                 <a:solidFill>
                   <a:srgbClr val="111111"/>
                 </a:solidFill>
@@ -16382,7 +16578,7 @@
               </a:defRPr>
             </a:pPr>
             <a:r>
-              <a:rPr sz="2400" b="0">
+              <a:rPr sz="2050" b="0">
                 <a:solidFill>
                   <a:srgbClr val="111111"/>
                 </a:solidFill>
@@ -16412,7 +16608,7 @@
         <p:spPr>
           <a:xfrm xmlns:a="http://schemas.openxmlformats.org/drawingml/2006/main">
             <a:off x="762000" y="3200400"/>
-            <a:ext cx="7620000" cy="838200"/>
+            <a:ext cx="3977639" cy="838200"/>
           </a:xfrm>
           <a:prstGeom xmlns:a="http://schemas.openxmlformats.org/drawingml/2006/main" prst="rect">
             <a:avLst/>
@@ -16440,7 +16636,7 @@
               </a:defRPr>
             </a:pPr>
             <a:r>
-              <a:rPr sz="2925" b="1">
+              <a:rPr sz="2650" b="1">
                 <a:solidFill>
                   <a:srgbClr val="064F91"/>
                 </a:solidFill>
@@ -16448,7 +16644,29 @@
                 <a:ea typeface="Calibri"/>
                 <a:cs typeface="Calibri"/>
               </a:rPr>
-              <a:t>IΔ = skillnaden mellan strömmarna</a:t>
+              <a:t>I</a:t>
+            </a:r>
+            <a:r>
+              <a:rPr sz="2650" b="1" baseline="-25000">
+                <a:solidFill>
+                  <a:srgbClr val="064F91"/>
+                </a:solidFill>
+                <a:latin typeface="Calibri"/>
+                <a:ea typeface="Calibri"/>
+                <a:cs typeface="Calibri"/>
+              </a:rPr>
+              <a:t>Δ</a:t>
+            </a:r>
+            <a:r>
+              <a:rPr sz="2650" b="1">
+                <a:solidFill>
+                  <a:srgbClr val="064F91"/>
+                </a:solidFill>
+                <a:latin typeface="Calibri"/>
+                <a:ea typeface="Calibri"/>
+                <a:cs typeface="Calibri"/>
+              </a:rPr>
+              <a:t> = skillnaden mellan strömmarna</a:t>
             </a:r>
           </a:p>
         </p:txBody>
@@ -16470,7 +16688,7 @@
         <p:spPr>
           <a:xfrm xmlns:a="http://schemas.openxmlformats.org/drawingml/2006/main">
             <a:off x="762000" y="4429125"/>
-            <a:ext cx="7620000" cy="1352550"/>
+            <a:ext cx="3977639" cy="1352550"/>
           </a:xfrm>
           <a:prstGeom xmlns:a="http://schemas.openxmlformats.org/drawingml/2006/main" prst="rect">
             <a:avLst/>
@@ -16498,7 +16716,7 @@
               </a:defRPr>
             </a:pPr>
             <a:r>
-              <a:rPr sz="2250" b="0">
+              <a:rPr sz="2100" b="0">
                 <a:solidFill>
                   <a:srgbClr val="111111"/>
                 </a:solidFill>
@@ -16522,7 +16740,7 @@
               </a:defRPr>
             </a:pPr>
             <a:r>
-              <a:rPr sz="2250" b="0">
+              <a:rPr sz="2100" b="0">
                 <a:solidFill>
                   <a:srgbClr val="111111"/>
                 </a:solidFill>
@@ -16593,6 +16811,30 @@
           </a:p>
         </p:txBody>
       </p:sp>
+      <p:pic xmlns:a="http://schemas.openxmlformats.org/drawingml/2006/main" xmlns:r="http://schemas.openxmlformats.org/officeDocument/2006/relationships">
+        <p:nvPicPr>
+          <p:cNvPr id="9" name="Figur: Jordfelsbrytare: L och N går genom en su" descr="Jordfelsbrytare: L och N går genom en summaströmtransformator; en läckström till jord ger skillnaden I-delta som påverkar utlösaren"/>
+          <p:cNvPicPr>
+            <a:picLocks noChangeAspect="1"/>
+          </p:cNvPicPr>
+          <p:nvPr/>
+        </p:nvPicPr>
+        <p:blipFill>
+          <a:blip r:embed="rId3"/>
+          <a:stretch>
+            <a:fillRect/>
+          </a:stretch>
+        </p:blipFill>
+        <p:spPr>
+          <a:xfrm>
+            <a:off x="4892040" y="1645920"/>
+            <a:ext cx="3886200" cy="3071293"/>
+          </a:xfrm>
+          <a:prstGeom prst="rect">
+            <a:avLst/>
+          </a:prstGeom>
+        </p:spPr>
+      </p:pic>
     </p:spTree>
     <p:extLst>
       <p:ext uri="{BB962C8B-B14F-4D97-AF65-F5344CB8AC3E}">
@@ -16713,7 +16955,7 @@
         <p:spPr>
           <a:xfrm xmlns:a="http://schemas.openxmlformats.org/drawingml/2006/main">
             <a:off x="762000" y="1571625"/>
-            <a:ext cx="7620000" cy="990600"/>
+            <a:ext cx="3977639" cy="990600"/>
           </a:xfrm>
           <a:prstGeom xmlns:a="http://schemas.openxmlformats.org/drawingml/2006/main" prst="rect">
             <a:avLst/>
@@ -16740,15 +16982,15 @@
               </a:defRPr>
             </a:pPr>
             <a:r>
-              <a:rPr sz="2175" b="0">
-                <a:solidFill>
-                  <a:srgbClr val="111111"/>
-                </a:solidFill>
-                <a:latin typeface="Calibri"/>
-                <a:ea typeface="Calibri"/>
-                <a:cs typeface="Calibri"/>
-              </a:rPr>
-              <a:t>En enfaskrets har 2,000 A ut och 1,985 A tillbaka genom de övervakade ledarna.</a:t>
+              <a:rPr sz="2100" b="0">
+                <a:solidFill>
+                  <a:srgbClr val="111111"/>
+                </a:solidFill>
+                <a:latin typeface="Calibri"/>
+                <a:ea typeface="Calibri"/>
+                <a:cs typeface="Calibri"/>
+              </a:rPr>
+              <a:t>En enfaskrets har 2,000 A ut och 1,985 A tillbaka genom de övervakade ledarna.</a:t>
             </a:r>
           </a:p>
         </p:txBody>
@@ -16770,7 +17012,7 @@
         <p:spPr>
           <a:xfrm xmlns:a="http://schemas.openxmlformats.org/drawingml/2006/main">
             <a:off x="762000" y="2705100"/>
-            <a:ext cx="7620000" cy="790575"/>
+            <a:ext cx="3977639" cy="790575"/>
           </a:xfrm>
           <a:prstGeom xmlns:a="http://schemas.openxmlformats.org/drawingml/2006/main" prst="rect">
             <a:avLst/>
@@ -16805,7 +17047,95 @@
                 <a:ea typeface="Calibri"/>
                 <a:cs typeface="Calibri"/>
               </a:rPr>
-              <a:t>IΔ = |Iut − Iretur|</a:t>
+              <a:t>I</a:t>
+            </a:r>
+            <a:r>
+              <a:rPr sz="2325" b="1" baseline="-25000">
+                <a:solidFill>
+                  <a:srgbClr val="064F91"/>
+                </a:solidFill>
+                <a:latin typeface="Calibri"/>
+                <a:ea typeface="Calibri"/>
+                <a:cs typeface="Calibri"/>
+              </a:rPr>
+              <a:t>Δ</a:t>
+            </a:r>
+            <a:r>
+              <a:rPr sz="2325" b="1">
+                <a:solidFill>
+                  <a:srgbClr val="064F91"/>
+                </a:solidFill>
+                <a:latin typeface="Calibri"/>
+                <a:ea typeface="Calibri"/>
+                <a:cs typeface="Calibri"/>
+              </a:rPr>
+              <a:t> = |</a:t>
+            </a:r>
+            <a:r>
+              <a:rPr sz="2325" b="1">
+                <a:solidFill>
+                  <a:srgbClr val="064F91"/>
+                </a:solidFill>
+                <a:latin typeface="Calibri"/>
+                <a:ea typeface="Calibri"/>
+                <a:cs typeface="Calibri"/>
+              </a:rPr>
+              <a:t>I</a:t>
+            </a:r>
+            <a:r>
+              <a:rPr sz="2325" b="1" baseline="-25000">
+                <a:solidFill>
+                  <a:srgbClr val="064F91"/>
+                </a:solidFill>
+                <a:latin typeface="Calibri"/>
+                <a:ea typeface="Calibri"/>
+                <a:cs typeface="Calibri"/>
+              </a:rPr>
+              <a:t>ut</a:t>
+            </a:r>
+            <a:r>
+              <a:rPr sz="2325" b="1">
+                <a:solidFill>
+                  <a:srgbClr val="064F91"/>
+                </a:solidFill>
+                <a:latin typeface="Calibri"/>
+                <a:ea typeface="Calibri"/>
+                <a:cs typeface="Calibri"/>
+              </a:rPr>
+              <a:t> − </a:t>
+            </a:r>
+            <a:r>
+              <a:rPr sz="2325" b="1">
+                <a:solidFill>
+                  <a:srgbClr val="064F91"/>
+                </a:solidFill>
+                <a:latin typeface="Calibri"/>
+                <a:ea typeface="Calibri"/>
+                <a:cs typeface="Calibri"/>
+              </a:rPr>
+              <a:t>I</a:t>
+            </a:r>
+            <a:r>
+              <a:rPr sz="2325" b="1" baseline="-25000">
+                <a:solidFill>
+                  <a:srgbClr val="064F91"/>
+                </a:solidFill>
+                <a:latin typeface="Calibri"/>
+                <a:ea typeface="Calibri"/>
+                <a:cs typeface="Calibri"/>
+              </a:rPr>
+              <a:t>retur</a:t>
+            </a:r>
+            <a:r>
+              <a:rPr sz="2325" b="1">
+                <a:solidFill>
+                  <a:srgbClr val="064F91"/>
+                </a:solidFill>
+                <a:latin typeface="Calibri"/>
+                <a:ea typeface="Calibri"/>
+                <a:cs typeface="Calibri"/>
+              </a:rPr>
+              <a:t>|</a:t>
             </a:r>
           </a:p>
         </p:txBody>
@@ -16827,7 +17157,7 @@
         <p:spPr>
           <a:xfrm xmlns:a="http://schemas.openxmlformats.org/drawingml/2006/main">
             <a:off x="762000" y="3657600"/>
-            <a:ext cx="7620000" cy="1524000"/>
+            <a:ext cx="3977639" cy="1524000"/>
           </a:xfrm>
           <a:prstGeom xmlns:a="http://schemas.openxmlformats.org/drawingml/2006/main" prst="rect">
             <a:avLst/>
@@ -16854,15 +17184,48 @@
               </a:defRPr>
             </a:pPr>
             <a:r>
-              <a:rPr sz="2063" b="0">
-                <a:solidFill>
-                  <a:srgbClr val="111111"/>
-                </a:solidFill>
-                <a:latin typeface="Calibri"/>
-                <a:ea typeface="Calibri"/>
-                <a:cs typeface="Calibri"/>
-              </a:rPr>
-              <a:t>1. IΔ = |2,000 − 1,985| = 0,015 A.</a:t>
+              <a:rPr sz="1800" b="0">
+                <a:solidFill>
+                  <a:srgbClr val="111111"/>
+                </a:solidFill>
+                <a:latin typeface="Calibri"/>
+                <a:ea typeface="Calibri"/>
+                <a:cs typeface="Calibri"/>
+              </a:rPr>
+              <a:t>1. </a:t>
+            </a:r>
+            <a:r>
+              <a:rPr sz="1800" b="0">
+                <a:solidFill>
+                  <a:srgbClr val="111111"/>
+                </a:solidFill>
+                <a:latin typeface="Calibri"/>
+                <a:ea typeface="Calibri"/>
+                <a:cs typeface="Calibri"/>
+              </a:rPr>
+              <a:t>I</a:t>
+            </a:r>
+            <a:r>
+              <a:rPr sz="1800" b="0" baseline="-25000">
+                <a:solidFill>
+                  <a:srgbClr val="111111"/>
+                </a:solidFill>
+                <a:latin typeface="Calibri"/>
+                <a:ea typeface="Calibri"/>
+                <a:cs typeface="Calibri"/>
+              </a:rPr>
+              <a:t>Δ</a:t>
+            </a:r>
+            <a:r>
+              <a:rPr sz="1800" b="0">
+                <a:solidFill>
+                  <a:srgbClr val="111111"/>
+                </a:solidFill>
+                <a:latin typeface="Calibri"/>
+                <a:ea typeface="Calibri"/>
+                <a:cs typeface="Calibri"/>
+              </a:rPr>
+              <a:t> = |2,000 − 1,985| = 0,015 A.</a:t>
             </a:r>
           </a:p>
           <a:p xmlns:a="http://schemas.openxmlformats.org/drawingml/2006/main">
@@ -16877,15 +17240,15 @@
               </a:defRPr>
             </a:pPr>
             <a:r>
-              <a:rPr sz="2063" b="0">
-                <a:solidFill>
-                  <a:srgbClr val="111111"/>
-                </a:solidFill>
-                <a:latin typeface="Calibri"/>
-                <a:ea typeface="Calibri"/>
-                <a:cs typeface="Calibri"/>
-              </a:rPr>
-              <a:t>2. 0,015 · 1 000 = 15 mA.</a:t>
+              <a:rPr sz="1800" b="0">
+                <a:solidFill>
+                  <a:srgbClr val="111111"/>
+                </a:solidFill>
+                <a:latin typeface="Calibri"/>
+                <a:ea typeface="Calibri"/>
+                <a:cs typeface="Calibri"/>
+              </a:rPr>
+              <a:t>2. 0,015 · 1 000 = 15 mA.</a:t>
             </a:r>
           </a:p>
           <a:p xmlns:a="http://schemas.openxmlformats.org/drawingml/2006/main">
@@ -16900,7 +17263,7 @@
               </a:defRPr>
             </a:pPr>
             <a:r>
-              <a:rPr sz="2063" b="0">
+              <a:rPr sz="1800" b="0">
                 <a:solidFill>
                   <a:srgbClr val="111111"/>
                 </a:solidFill>
@@ -16930,7 +17293,7 @@
         <p:spPr>
           <a:xfrm xmlns:a="http://schemas.openxmlformats.org/drawingml/2006/main">
             <a:off x="762000" y="5372100"/>
-            <a:ext cx="7620000" cy="685800"/>
+            <a:ext cx="3977639" cy="685800"/>
           </a:xfrm>
           <a:prstGeom xmlns:a="http://schemas.openxmlformats.org/drawingml/2006/main" prst="rect">
             <a:avLst/>
@@ -16957,7 +17320,7 @@
               </a:defRPr>
             </a:pPr>
             <a:r>
-              <a:rPr sz="1913" b="0">
+              <a:rPr sz="1550" b="0">
                 <a:solidFill>
                   <a:srgbClr val="111111"/>
                 </a:solidFill>
@@ -17027,6 +17390,30 @@
           </a:p>
         </p:txBody>
       </p:sp>
+      <p:pic xmlns:a="http://schemas.openxmlformats.org/drawingml/2006/main" xmlns:r="http://schemas.openxmlformats.org/officeDocument/2006/relationships">
+        <p:nvPicPr>
+          <p:cNvPr id="16" name="Figur: Jordfelsbrytare med 2,000 A ut och 1,985" descr="Jordfelsbrytare med 2,000 A ut och 1,985 A tillbaka; differensströmmen 15 mA"/>
+          <p:cNvPicPr>
+            <a:picLocks noChangeAspect="1"/>
+          </p:cNvPicPr>
+          <p:nvPr/>
+        </p:nvPicPr>
+        <p:blipFill>
+          <a:blip r:embed="rId3"/>
+          <a:stretch>
+            <a:fillRect/>
+          </a:stretch>
+        </p:blipFill>
+        <p:spPr>
+          <a:xfrm>
+            <a:off x="4892040" y="1645920"/>
+            <a:ext cx="3886200" cy="3071293"/>
+          </a:xfrm>
+          <a:prstGeom prst="rect">
+            <a:avLst/>
+          </a:prstGeom>
+        </p:spPr>
+      </p:pic>
     </p:spTree>
     <p:extLst>
       <p:ext uri="{BB962C8B-B14F-4D97-AF65-F5344CB8AC3E}">

</xml_diff>

<commit_message>
Vecka 43: rättelser efter granskning (lärare, elinstallatör, sjöingenjör)
- Stödbilder vägleder i stället för att ge svaret, hållkretsexemplet avslöjar inte
  övning 3, 4 och 10, startfrågan avslöjar inte övning 3
- Fartyg: IT-nät och jordfelsbrytare, DC-mellanled ca 620 V vid 440 V, 440 V kontaktor,
  selektivitet ombord
- Figurer: IEC-symbol för NC, fler varv på primärsidan, plintnummer på kontaktorn,
  K1 dragen i övning 7, ingen svarsledtråd i stödbild 5
- Hållkretslabbet: bara 24 V, två 0 V-uppgifter (hållning, efter strömavbrott),
  dolt fel i diagnosuppgiften, stegvisa ledtrådar, förklaring av flytande punkter
- lab.css: panelen kan inte bli bredare än sin kolumn

Co-Authored-By: Claude Opus 5.5 <noreply@anthropic.com>
Claude-Session: https://claude.ai/code/session_011V9KjBb53XrDm23Dw58SH3
</commit_message>
<xml_diff>
--- a/sjoskolan/vecka-43/aktuell/v43_01_Komponenter_och_skydd_elev.pptx
+++ b/sjoskolan/vecka-43/aktuell/v43_01_Komponenter_och_skydd_elev.pptx
@@ -3512,6 +3512,10 @@
             <a:noFill/>
           </a:ln>
         </p:spPr>
+        <p:txBody xmlns:a="http://schemas.openxmlformats.org/drawingml/2006/main">
+          <a:bodyPr/>
+          <a:p/>
+        </p:txBody>
       </p:sp>
       <p:sp>
         <p:nvSpPr>
@@ -3842,7 +3846,7 @@
                 <a:ea typeface="Calibri"/>
                 <a:cs typeface="Calibri"/>
               </a:rPr>
-              <a:t>Spole styr kontaktor, huvudkontakter kopplar last</a:t>
+              <a:t>Vad händer när spolen får matning?</a:t>
             </a:r>
           </a:p>
         </p:txBody>
@@ -3899,7 +3903,7 @@
                 <a:ea typeface="Calibri"/>
                 <a:cs typeface="Calibri"/>
               </a:rPr>
-              <a:t>Spolen tillhör manöverkretsen. Huvudkontakterna öppnar eller sluter kraftvägen till motorn.</a:t>
+              <a:t>Spolen tillhör manöverkretsen. Huvudkontakterna ligger i kraftvägen till motorn.</a:t>
             </a:r>
           </a:p>
         </p:txBody>
@@ -4566,7 +4570,7 @@
                 <a:ea typeface="Calibri"/>
                 <a:cs typeface="Calibri"/>
               </a:rPr>
-              <a:t>Överström omfattar överlast och kortslutning</a:t>
+              <a:t>Vilka slags överström kan uppstå?</a:t>
             </a:r>
           </a:p>
         </p:txBody>
@@ -4623,7 +4627,7 @@
                 <a:ea typeface="Calibri"/>
                 <a:cs typeface="Calibri"/>
               </a:rPr>
-              <a:t>Överlast är för hög ström i en i övrigt avsedd strömväg. Kortslutning ger en oavsiktlig lågimpediv väg.</a:t>
+              <a:t>Tänk på en för stor last i en hel krets och på en oavsiktlig väg med låg impedans.</a:t>
             </a:r>
           </a:p>
         </p:txBody>
@@ -6872,7 +6876,7 @@
                 <a:ea typeface="Calibri"/>
                 <a:cs typeface="Calibri"/>
               </a:rPr>
-              <a:t>Jordfelsfunktion reagerar på differensström</a:t>
+              <a:t>Vad mäter jordfelsfunktionen?</a:t>
             </a:r>
           </a:p>
         </p:txBody>
@@ -6921,15 +6925,15 @@
               </a:defRPr>
             </a:pPr>
             <a:r>
-              <a:rPr sz="1650" b="0">
-                <a:solidFill>
-                  <a:srgbClr val="111111"/>
-                </a:solidFill>
-                <a:latin typeface="Calibri"/>
-                <a:ea typeface="Calibri"/>
-                <a:cs typeface="Calibri"/>
-              </a:rPr>
-              <a:t>Om all ström återkommer genom de övervakade ledarna är differensen nära noll, även vid stor lastström.</a:t>
+              <a:rPr sz="1700" b="0">
+                <a:solidFill>
+                  <a:srgbClr val="111111"/>
+                </a:solidFill>
+                <a:latin typeface="Calibri"/>
+                <a:ea typeface="Calibri"/>
+                <a:cs typeface="Calibri"/>
+              </a:rPr>
+              <a:t>Jämför strömmen ut med strömmen tillbaka i de övervakade ledarna, även när lastströmmen är stor.</a:t>
             </a:r>
           </a:p>
         </p:txBody>
@@ -8448,7 +8452,31 @@
                 <a:ea typeface="Calibri"/>
                 <a:cs typeface="Calibri"/>
               </a:rPr>
-              <a:t>NO: normalt öppen     NC: normalt sluten</a:t>
+              <a:t>NO: normalt öppen</a:t>
+            </a:r>
+          </a:p>
+          <a:p xmlns:a="http://schemas.openxmlformats.org/drawingml/2006/main">
+            <a:pPr algn="l">
+              <a:buNone/>
+              <a:defRPr sz="2925" b="1">
+                <a:solidFill>
+                  <a:srgbClr val="064F91"/>
+                </a:solidFill>
+                <a:latin typeface="Calibri"/>
+                <a:ea typeface="Calibri"/>
+                <a:cs typeface="Calibri"/>
+              </a:defRPr>
+            </a:pPr>
+            <a:r>
+              <a:rPr sz="2650" b="1">
+                <a:solidFill>
+                  <a:srgbClr val="064F91"/>
+                </a:solidFill>
+                <a:latin typeface="Calibri"/>
+                <a:ea typeface="Calibri"/>
+                <a:cs typeface="Calibri"/>
+              </a:rPr>
+              <a:t>NC: normalt sluten</a:t>
             </a:r>
           </a:p>
         </p:txBody>
@@ -10746,7 +10774,7 @@
                 <a:ea typeface="Calibri"/>
                 <a:cs typeface="Calibri"/>
               </a:rPr>
-              <a:t>Spoldata gäller manöverkretsen</a:t>
+              <a:t>Vilken del av apparaten gäller varje märkvärde?</a:t>
             </a:r>
           </a:p>
         </p:txBody>
@@ -10860,7 +10888,7 @@
                 <a:ea typeface="Calibri"/>
                 <a:cs typeface="Calibri"/>
               </a:rPr>
-              <a:t>Förutsättningar: Huvudkontakter för 400 V, spole märkt 24 V DC.</a:t>
+              <a:t>Förutsättningar: Huvudkontakter för 440 V, spole märkt 24 V DC.</a:t>
             </a:r>
           </a:p>
         </p:txBody>
@@ -11194,7 +11222,7 @@
                 <a:ea typeface="Calibri"/>
                 <a:cs typeface="Calibri"/>
               </a:rPr>
-              <a:t>En kontaktor har huvudkontakter för 400 V men en spole märkt 24 V DC. Vilken uppgift styr spolens matning?</a:t>
+              <a:t>En kontaktor har huvudkontakter för 440 V men en spole märkt 24 V DC. Vilken uppgift styr spolens matning?</a:t>
             </a:r>
           </a:p>
         </p:txBody>
@@ -11470,7 +11498,7 @@
                 <a:ea typeface="Calibri"/>
                 <a:cs typeface="Calibri"/>
               </a:rPr>
-              <a:t>Selektivitet begränsar bortkopplingen till felområdet</a:t>
+              <a:t>Vilket skydd borde ha löst?</a:t>
             </a:r>
           </a:p>
         </p:txBody>
@@ -13432,7 +13460,7 @@
                 <a:ea typeface="Calibri"/>
                 <a:cs typeface="Calibri"/>
               </a:rPr>
-              <a:t>Manöver, överlastskydd och kortslutningsskydd</a:t>
+              <a:t>Vilka funktioner behövs runt motorn?</a:t>
             </a:r>
           </a:p>
         </p:txBody>
@@ -13489,7 +13517,7 @@
                 <a:ea typeface="Calibri"/>
                 <a:cs typeface="Calibri"/>
               </a:rPr>
-              <a:t>Kontaktor manövrerar. Överlastfunktion skyddar vid för hög belastning. Kortslutningsskydd hanterar felström.</a:t>
+              <a:t>Tänk på normal start och stopp, på för hög belastning och på en kortslutning i kabel eller motor.</a:t>
             </a:r>
           </a:p>
         </p:txBody>
@@ -16716,7 +16744,7 @@
               </a:defRPr>
             </a:pPr>
             <a:r>
-              <a:rPr sz="2100" b="0">
+              <a:rPr sz="1550" b="0">
                 <a:solidFill>
                   <a:srgbClr val="111111"/>
                 </a:solidFill>
@@ -16740,15 +16768,15 @@
               </a:defRPr>
             </a:pPr>
             <a:r>
-              <a:rPr sz="2100" b="0">
-                <a:solidFill>
-                  <a:srgbClr val="111111"/>
-                </a:solidFill>
-                <a:latin typeface="Calibri"/>
-                <a:ea typeface="Calibri"/>
-                <a:cs typeface="Calibri"/>
-              </a:rPr>
-              <a:t>RCBO kombinerar funktionerna när det framgår av data.</a:t>
+              <a:rPr sz="1550" b="0">
+                <a:solidFill>
+                  <a:srgbClr val="111111"/>
+                </a:solidFill>
+                <a:latin typeface="Calibri"/>
+                <a:ea typeface="Calibri"/>
+                <a:cs typeface="Calibri"/>
+              </a:rPr>
+              <a:t>Ombord: i 440 V IT-nät ger första jordfelet larm, inte utlösning. Jordfelsbrytare används främst i 230 V uttagsgrupper.</a:t>
             </a:r>
           </a:p>
         </p:txBody>

</xml_diff>

<commit_message>
Sjöskolan vecka 41–45: delsidor som vecka 40, lärarmanus och ritningar för 43–45
Ny exportör delsidor_veckor.py: en sida per del med översikt, teori och exempel ur presentationen, övningar med ledtråd 1–3, räknarhjälp, facit och avbockning. Veckosidorna länkar till delsidorna. Vecka 43–45: numrering i passbilderna, ritningar som bilder (scheman_veckor.py), lärarkopior med manus i portalen.

Co-Authored-By: Claude Opus 5.5 <noreply@anthropic.com>
Claude-Session: https://claude.ai/code/session_011V9KjBb53XrDm23Dw58SH3
</commit_message>
<xml_diff>
--- a/sjoskolan/vecka-43/aktuell/v43_01_Komponenter_och_skydd_elev.pptx
+++ b/sjoskolan/vecka-43/aktuell/v43_01_Komponenter_och_skydd_elev.pptx
@@ -8060,7 +8060,7 @@
                 <a:ea typeface="Calibri"/>
                 <a:cs typeface="Calibri"/>
               </a:rPr>
-              <a:t>Teori och exempel följs av övning 6–10.</a:t>
+              <a:t>Teori och exempel följs av övning 1.6–1.10.</a:t>
             </a:r>
           </a:p>
           <a:p xmlns:a="http://schemas.openxmlformats.org/drawingml/2006/main">
@@ -11900,7 +11900,7 @@
                 <a:ea typeface="Calibri"/>
                 <a:cs typeface="Calibri"/>
               </a:rPr>
-              <a:t>15 min övning 1, 2, 4, 5 min återkoppling</a:t>
+              <a:t>15 min övning 1.1, 1.2 och 1.4, 5 min återkoppling</a:t>
             </a:r>
           </a:p>
         </p:txBody>
@@ -12014,7 +12014,7 @@
                 <a:ea typeface="Calibri"/>
                 <a:cs typeface="Calibri"/>
               </a:rPr>
-              <a:t>20 min teori och exempel, 15 min övning 6, 7, 8</a:t>
+              <a:t>20 min teori och exempel, 15 min övning 1.6, 1.7 och 1.8</a:t>
             </a:r>
           </a:p>
           <a:p xmlns:a="http://schemas.openxmlformats.org/drawingml/2006/main">

</xml_diff>

<commit_message>
Sjöskolan vecka 43: rätta facit, ledtrådar som gav svaret, notation och delsidornas numrering
Facit för 2.2 och 1.5, fysikfel i ledtråd 3.6, sju ledtrådar som gav svaret, övningar som gav
inlämning 1:s svar, entydig inlämning 2 b, nedsänkta index, enklare frågor, interna koder borta i
Hållkretslabbet. Delsidorna i vecka 43 och 44 räknar med de flyttade delarna (av 4, av 5).

Co-Authored-By: Claude Opus 5.5 <noreply@anthropic.com>
Claude-Session: https://claude.ai/code/session_01E6DNWu8trXB9zSZC1cgTtp
</commit_message>
<xml_diff>
--- a/sjoskolan/vecka-43/aktuell/v43_01_Komponenter_och_skydd_elev.pptx
+++ b/sjoskolan/vecka-43/aktuell/v43_01_Komponenter_och_skydd_elev.pptx
@@ -5408,7 +5408,7 @@
                 <a:ea typeface="Calibri"/>
                 <a:cs typeface="Calibri"/>
               </a:rPr>
-              <a:t>Förutsättningar: Dvärgbrytaren är märkt 16 A och 6 kA. Brytförmågan gäller under de villkor som anges i märkningen.</a:t>
+              <a:t>Förutsättningar: Dvärgbrytaren är märkt 16 A och 6 kA.</a:t>
             </a:r>
           </a:p>
         </p:txBody>
@@ -6018,7 +6018,29 @@
                 <a:ea typeface="Calibri"/>
                 <a:cs typeface="Calibri"/>
               </a:rPr>
-              <a:t>IΔ = |I</a:t>
+              <a:t>I</a:t>
+            </a:r>
+            <a:r>
+              <a:rPr sz="2400" b="1" baseline="-25000">
+                <a:solidFill>
+                  <a:srgbClr val="064F91"/>
+                </a:solidFill>
+                <a:latin typeface="Calibri"/>
+                <a:ea typeface="Calibri"/>
+                <a:cs typeface="Calibri"/>
+              </a:rPr>
+              <a:t>Δ</a:t>
+            </a:r>
+            <a:r>
+              <a:rPr sz="2400" b="1">
+                <a:solidFill>
+                  <a:srgbClr val="064F91"/>
+                </a:solidFill>
+                <a:latin typeface="Calibri"/>
+                <a:ea typeface="Calibri"/>
+                <a:cs typeface="Calibri"/>
+              </a:rPr>
+              <a:t> = |I</a:t>
             </a:r>
             <a:r>
               <a:rPr sz="2400" b="1" baseline="-25000">
@@ -6119,7 +6141,29 @@
                 <a:ea typeface="Calibri"/>
                 <a:cs typeface="Calibri"/>
               </a:rPr>
-              <a:t>IΔ är differensströmmen.</a:t>
+              <a:t>I</a:t>
+            </a:r>
+            <a:r>
+              <a:rPr sz="2050" b="0" baseline="-25000">
+                <a:solidFill>
+                  <a:srgbClr val="111111"/>
+                </a:solidFill>
+                <a:latin typeface="Calibri"/>
+                <a:ea typeface="Calibri"/>
+                <a:cs typeface="Calibri"/>
+              </a:rPr>
+              <a:t>Δ</a:t>
+            </a:r>
+            <a:r>
+              <a:rPr sz="2050" b="0">
+                <a:solidFill>
+                  <a:srgbClr val="111111"/>
+                </a:solidFill>
+                <a:latin typeface="Calibri"/>
+                <a:ea typeface="Calibri"/>
+                <a:cs typeface="Calibri"/>
+              </a:rPr>
+              <a:t> är differensströmmen.</a:t>
             </a:r>
           </a:p>
         </p:txBody>
@@ -7282,7 +7326,7 @@
                 <a:ea typeface="Calibri"/>
                 <a:cs typeface="Calibri"/>
               </a:rPr>
-              <a:t>En jordfelsbrytare utan överströmsskydd matar en last som drar för stor ström, men all ström kommer tillbaka. Varför behövs ändå ett överströmsskydd?</a:t>
+              <a:t>En jordfelsbrytare har inget överströmsskydd. Lasten drar för mycket ström, men all ström kommer tillbaka. Varför behövs ett överströmsskydd också?</a:t>
             </a:r>
           </a:p>
         </p:txBody>
@@ -10879,7 +10923,7 @@
                 <a:ea typeface="Calibri"/>
                 <a:cs typeface="Calibri"/>
               </a:rPr>
-              <a:t>Arbetsgång: Ta spolens spänning och strömart (AC eller DC) från dess märkning, inte huvudkontakternas värde.</a:t>
+              <a:t>Arbetsgång: Huvudkontakterna och spolen har var sin märkning. Vilken del av kontaktorn är det som matas från manöverkretsen?</a:t>
             </a:r>
           </a:p>
         </p:txBody>
@@ -11156,7 +11200,7 @@
                 <a:ea typeface="Calibri"/>
                 <a:cs typeface="Calibri"/>
               </a:rPr>
-              <a:t>En kontaktor har huvudkontakter för 440 V men en spole märkt 24 V DC. Vilken uppgift styr spolens matning?</a:t>
+              <a:t>Kontaktorns huvudkontakter är märkta 440 V. Spolen är märkt 24 V DC. Vilken spänning ska spolen matas med?</a:t>
             </a:r>
           </a:p>
         </p:txBody>
@@ -12394,7 +12438,7 @@
                 <a:ea typeface="Calibri"/>
                 <a:cs typeface="Calibri"/>
               </a:rPr>
-              <a:t>Ett fel i en undercentral gör att både gruppskyddet och huvudskyddet löser ut. Vad behöver utredas?</a:t>
+              <a:t>Ett fel i en undercentral (en mindre elcentral längre ut i nätet) gör att två skydd löser: gruppskyddet och huvudskyddet. Bara gruppskyddet borde ha löst. Vad behöver du ta reda på?</a:t>
             </a:r>
           </a:p>
         </p:txBody>
@@ -13118,7 +13162,7 @@
                 <a:ea typeface="Calibri"/>
                 <a:cs typeface="Calibri"/>
               </a:rPr>
-              <a:t>Den beräknade kortslutningsströmmen är 8 kA. Det föreslagna skyddet har brytförmågan 6 kA, och det finns inget dokumenterat backupskydd. Kan valet godkännas?</a:t>
+              <a:t>Kortslutningsströmmen kan bli 8 kA. Skyddet klarar att bryta 6 kA. Det finns inget annat skydd som hjälper till (backupskydd). Får du använda skyddet?</a:t>
             </a:r>
           </a:p>
         </p:txBody>

</xml_diff>

<commit_message>
Sjöskolan vecka 43 måndag och tisdag: läxor, upplägg och avslutsfrågor stämmer med inlämningen
Måndagen ger inlämningens uppgift 2 och tisdagen uppgift 1 (som behöver del 2).
Tisdagens upplägg följer bildernas ordning. Avslutsfrågorna pekar på
inlämningens uppgifter, ledtråd 3 i övning 1.4 räknar inte med inlämningens tal,
och delsidornas labbavsnitt länkar till Hela veckan.

Co-Authored-By: Claude Opus 5.5 <noreply@anthropic.com>
Claude-Session: https://claude.ai/code/session_01E6DNWu8trXB9zSZC1cgTtp
</commit_message>
<xml_diff>
--- a/sjoskolan/vecka-43/aktuell/v43_01_Komponenter_och_skydd_elev.pptx
+++ b/sjoskolan/vecka-43/aktuell/v43_01_Komponenter_och_skydd_elev.pptx
@@ -3493,7 +3493,7 @@
         <p:spPr>
           <a:xfrm>
             <a:off x="548640" y="1005840"/>
-            <a:ext cx="6035040" cy="1645920"/>
+            <a:ext cx="6035040" cy="914400"/>
           </a:xfrm>
           <a:prstGeom prst="rect">
             <a:avLst/>
@@ -3534,7 +3534,7 @@
         </p:nvSpPr>
         <p:spPr>
           <a:xfrm>
-            <a:off x="548640" y="2697480"/>
+            <a:off x="548640" y="1965960"/>
             <a:ext cx="5669280" cy="914400"/>
           </a:xfrm>
           <a:prstGeom prst="rect">
@@ -3576,7 +3576,7 @@
         </p:nvSpPr>
         <p:spPr>
           <a:xfrm>
-            <a:off x="548640" y="3703320"/>
+            <a:off x="548640" y="2971800"/>
             <a:ext cx="5852160" cy="411480"/>
           </a:xfrm>
           <a:prstGeom prst="rect">
@@ -6953,7 +6953,7 @@
                 </a:solidFill>
                 <a:latin typeface="Calibri"/>
               </a:rPr>
-              <a:t>Identifiera skydd och manöverkomponenter inför veckans motorstyrningsschema. Dokumentera funktion och vilken data som behövs.</a:t>
+              <a:t>Uppgiften Skyddsdata i inlämningen bygger på del 1. Inlämningen senast fredag 23 oktober.</a:t>
             </a:r>
           </a:p>
         </p:txBody>
@@ -7533,7 +7533,7 @@
                 </a:solidFill>
                 <a:latin typeface="Calibri"/>
               </a:rPr>
-              <a:t>3. Börja på inlämningen: uppgift 1 och 2.</a:t>
+              <a:t>3. Börja på inlämningen: uppgift 2, skyddsdata. Den bygger på del 1.</a:t>
             </a:r>
           </a:p>
           <a:p>
@@ -7571,7 +7571,7 @@
                 </a:solidFill>
                 <a:latin typeface="Calibri"/>
               </a:rPr>
-              <a:t>Inlämningen och felsökningsrapporten senast fredag 23 oktober. Allt finns på veckosidan.</a:t>
+              <a:t>Inlämningen, uppgift 1–4, senast fredag 23 oktober. Allt finns på veckosidan.</a:t>
             </a:r>
           </a:p>
         </p:txBody>

</xml_diff>